<commit_message>
docs: de-slop results guide and slide/notebook generators, regenerate artifacts
Remove em/en dashes and buzzwords from results/README, the slide text, and the
notebook generators, then regenerate the deck and notebooks so the rendered
output matches. No tokens, numbers, or logic changed.
</commit_message>
<xml_diff>
--- a/slides/ECS111_slides.pptx
+++ b/slides/ECS111_slides.pptx
@@ -3161,7 +3161,7 @@
                   <a:srgbClr val="222222"/>
                 </a:solidFill>
               </a:rPr>
-              <a:t>ECS 111 — Final Project</a:t>
+              <a:t>ECS 111 Final Project</a:t>
             </a:r>
           </a:p>
         </p:txBody>
@@ -3612,7 +3612,7 @@
                   <a:srgbClr val="222222"/>
                 </a:solidFill>
               </a:rPr>
-              <a:t>– Understand the question, locate the right cells, pick the operation, format the answer.</a:t>
+              <a:t>- Understand the question, locate the right cells, pick the operation, format the answer.</a:t>
             </a:r>
           </a:p>
           <a:p>
@@ -3627,7 +3627,7 @@
                   <a:srgbClr val="222222"/>
                 </a:solidFill>
               </a:rPr>
-              <a:t>– A failure at any step yields a confident wrong answer.</a:t>
+              <a:t>- A failure at any step yields a confident wrong answer.</a:t>
             </a:r>
           </a:p>
           <a:p>
@@ -3657,7 +3657,7 @@
                   <a:srgbClr val="222222"/>
                 </a:solidFill>
               </a:rPr>
-              <a:t>• We study the under-explored regime: small models that run for free on Colab.</a:t>
+              <a:t>• We look at the case most studies skip: small models that run for free on Colab.</a:t>
             </a:r>
           </a:p>
         </p:txBody>
@@ -3776,7 +3776,7 @@
                   <a:srgbClr val="222222"/>
                 </a:solidFill>
               </a:rPr>
-              <a:t>– CoT risk: small models may copy surface patterns without the underlying logic.</a:t>
+              <a:t>- CoT risk: small models may copy surface patterns without the underlying logic.</a:t>
             </a:r>
           </a:p>
           <a:p>
@@ -3791,7 +3791,7 @@
                   <a:srgbClr val="222222"/>
                 </a:solidFill>
               </a:rPr>
-              <a:t>– Fine-tuning risk: overfitting to dataset-specific shortcuts that collapse on new formats.</a:t>
+              <a:t>- Fine-tuning risk: overfitting to dataset-specific shortcuts that collapse on new formats.</a:t>
             </a:r>
           </a:p>
           <a:p>
@@ -5773,7 +5773,7 @@
                   <a:srgbClr val="222222"/>
                 </a:solidFill>
               </a:rPr>
-              <a:t>– We transfer the two fine-tuned base models to TabFact. Large is prompt-only (fine-tuning it OOMs on a free T4), so it has no transfer checkpoint.</a:t>
+              <a:t>- We transfer the two fine-tuned base models to TabFact. Large is prompt-only (fine-tuning it OOMs on a free T4), so it has no transfer checkpoint.</a:t>
             </a:r>
           </a:p>
           <a:p>
@@ -5937,7 +5937,7 @@
                   <a:srgbClr val="222222"/>
                 </a:solidFill>
               </a:rPr>
-              <a:t>– Lookup: failed to find the right cell. Share of errors: 29%.</a:t>
+              <a:t>- Lookup: failed to find the right cell. Share of errors: 29%.</a:t>
             </a:r>
           </a:p>
           <a:p>
@@ -5952,7 +5952,7 @@
                   <a:srgbClr val="222222"/>
                 </a:solidFill>
               </a:rPr>
-              <a:t>– Aggregation: failed at sum, count, max, or similar. Share: 57%.</a:t>
+              <a:t>- Aggregation: failed at sum, count, max, or similar. Share: 57%.</a:t>
             </a:r>
           </a:p>
           <a:p>
@@ -5967,7 +5967,7 @@
                   <a:srgbClr val="222222"/>
                 </a:solidFill>
               </a:rPr>
-              <a:t>– Multi-hop: failed to chain multiple steps. Share: 14%.</a:t>
+              <a:t>- Multi-hop: failed to chain multiple steps. Share: 14%.</a:t>
             </a:r>
           </a:p>
           <a:p>

</xml_diff>